<commit_message>
Talk: show the full 96 in member in the global mode, trim slides
- slide 11 shows the lowest global mode over the whole member (new
  analysis/07_talk_figures.jl), the distortional mode stays on the lower segment
- removed or reordered several slides, closing slide repeats the title slide

Co-Authored-By: Claude Sonnet 5.5 <noreply@anthropic.com>
</commit_message>
<xml_diff>
--- a/presentation/Moen_Shabhari_ICCFSS_2026.pptx
+++ b/presentation/Moen_Shabhari_ICCFSS_2026.pptx
@@ -4297,7 +4297,7 @@
                   <a:srgbClr val="0E2841"/>
                 </a:solidFill>
               </a:rPr>
-              <a:t>Distortional and global modes, lower 48 in braced segment</a:t>
+              <a:t>Distortional and global modes</a:t>
             </a:r>
           </a:p>
         </p:txBody>
@@ -4355,14 +4355,14 @@
                   <a:srgbClr val="4B5666"/>
                 </a:solidFill>
               </a:rPr>
-              <a:t>Lowest distortional mode, 36.51 kN: three half-waves per braced segment, the brace plane is a node</a:t>
+              <a:t>Lowest distortional mode, 36.51 kN, lower 48 in braced segment: three half-waves per braced segment, the brace plane is a node</a:t>
             </a:r>
           </a:p>
         </p:txBody>
       </p:sp>
       <p:pic>
         <p:nvPicPr>
-          <p:cNvPr id="5" name="Picture 4" descr="fig_mode_global.png"/>
+          <p:cNvPr id="5" name="Picture 4" descr="fig_mode_global_full.png"/>
           <p:cNvPicPr>
             <a:picLocks noChangeAspect="1"/>
           </p:cNvPicPr>
@@ -4376,8 +4376,8 @@
         </p:blipFill>
         <p:spPr>
           <a:xfrm>
-            <a:off x="2577465" y="3931920"/>
-            <a:ext cx="7098030" cy="2103120"/>
+            <a:off x="1097280" y="3931920"/>
+            <a:ext cx="10058400" cy="1955800"/>
           </a:xfrm>
           <a:prstGeom prst="rect">
             <a:avLst/>
@@ -4392,7 +4392,7 @@
         </p:nvSpPr>
         <p:spPr>
           <a:xfrm>
-            <a:off x="1097280" y="6080760"/>
+            <a:off x="1097280" y="5933440"/>
             <a:ext cx="10058400" cy="457200"/>
           </a:xfrm>
           <a:prstGeom prst="rect">
@@ -4413,7 +4413,7 @@
                   <a:srgbClr val="4B5666"/>
                 </a:solidFill>
               </a:rPr>
-              <a:t>Lowest global mode, 35.25 kN: lateral translation plus twist in each segment, one half-wave</a:t>
+              <a:t>Lowest global mode, 35.25 kN, full 96 in member: lateral translation plus twist, one half-wave in each braced segment, the brace at midheight is a node</a:t>
             </a:r>
           </a:p>
         </p:txBody>

</xml_diff>

<commit_message>
Link the talk from the README and fix the PowerPoint layout
Add a Presentation section with the GitHub Pages link to the slides plus the PDF and
PowerPoint downloads. In build_pptx.py, resize the inherited Two Content placeholders
without collapsing their width (slide 3 text rendered as a one-character column), move
the acknowledgement on slide 2 below the bullets, give slide 4's text room above the
mesh figure, and keep the title-slide URL inside the slide.

Co-Authored-By: Claude Opus 5.5 <noreply@anthropic.com>
</commit_message>
<xml_diff>
--- a/presentation/Moen_Shabhari_ICCFSS_2026.pptx
+++ b/presentation/Moen_Shabhari_ICCFSS_2026.pptx
@@ -3951,8 +3951,8 @@
         </p:nvSpPr>
         <p:spPr>
           <a:xfrm>
-            <a:off x="8138160" y="6446520"/>
-            <a:ext cx="3840480" cy="274320"/>
+            <a:off x="7223760" y="6446520"/>
+            <a:ext cx="4572000" cy="274320"/>
           </a:xfrm>
           <a:prstGeom prst="rect">
             <a:avLst/>
@@ -5353,8 +5353,8 @@
         </p:nvSpPr>
         <p:spPr>
           <a:xfrm>
-            <a:off x="8138160" y="6446520"/>
-            <a:ext cx="3840480" cy="274320"/>
+            <a:off x="7223760" y="6446520"/>
+            <a:ext cx="4572000" cy="274320"/>
           </a:xfrm>
           <a:prstGeom prst="rect">
             <a:avLst/>
@@ -5560,7 +5560,7 @@
         </p:nvSpPr>
         <p:spPr>
           <a:xfrm>
-            <a:off x="822960" y="4572000"/>
+            <a:off x="822960" y="5669280"/>
             <a:ext cx="10515600" cy="457200"/>
           </a:xfrm>
           <a:prstGeom prst="rect">
@@ -5702,7 +5702,8 @@
         </p:nvSpPr>
         <p:spPr>
           <a:xfrm>
-            <a:ext cx="0" cy="3566160"/>
+            <a:off x="838200" y="1825625"/>
+            <a:ext cx="5181600" cy="3566160"/>
           </a:xfrm>
         </p:spPr>
         <p:txBody>
@@ -5766,7 +5767,8 @@
         </p:nvSpPr>
         <p:spPr>
           <a:xfrm>
-            <a:ext cx="0" cy="3566160"/>
+            <a:off x="6172200" y="1825625"/>
+            <a:ext cx="5181600" cy="3566160"/>
           </a:xfrm>
         </p:spPr>
         <p:txBody>
@@ -5975,7 +5977,8 @@
         </p:nvSpPr>
         <p:spPr>
           <a:xfrm>
-            <a:ext cx="0" cy="2103120"/>
+            <a:off x="838200" y="1825625"/>
+            <a:ext cx="5181600" cy="2377440"/>
           </a:xfrm>
         </p:spPr>
         <p:txBody>
@@ -6036,7 +6039,8 @@
         </p:nvSpPr>
         <p:spPr>
           <a:xfrm>
-            <a:ext cx="0" cy="2103120"/>
+            <a:off x="6172200" y="1825625"/>
+            <a:ext cx="5181600" cy="2377440"/>
           </a:xfrm>
         </p:spPr>
         <p:txBody>
@@ -6082,8 +6086,8 @@
         </p:blipFill>
         <p:spPr>
           <a:xfrm>
-            <a:off x="1801368" y="3657600"/>
-            <a:ext cx="8558784" cy="2377440"/>
+            <a:off x="2295144" y="3977639"/>
+            <a:ext cx="7571232" cy="2103120"/>
           </a:xfrm>
           <a:prstGeom prst="rect">
             <a:avLst/>
@@ -6098,7 +6102,7 @@
         </p:nvSpPr>
         <p:spPr>
           <a:xfrm>
-            <a:off x="822960" y="6080760"/>
+            <a:off x="822960" y="6126479"/>
             <a:ext cx="10515600" cy="457200"/>
           </a:xfrm>
           <a:prstGeom prst="rect">

</xml_diff>